<commit_message>
Proofread gpqa with Japanese proofreading skill
</commit_message>
<xml_diff>
--- a/slides/datasets-in-10-minutes-gpqa.pptx
+++ b/slides/datasets-in-10-minutes-gpqa.pptx
@@ -9162,7 +9162,7 @@
                 <a:ea typeface="Noto Sans CJK JP"/>
                 <a:cs typeface="Noto Sans"/>
               </a:rPr>
-              <a:t>この会話では、極性が似た化合物のスポットが重なり、分離しにくいことを指す。</a:t>
+              <a:t>この会話は、極性が似た化合物のスポットが重なり、分離しにくい状況を指している。</a:t>
             </a:r>
           </a:p>
         </p:txBody>
@@ -16637,7 +16637,7 @@
                 <a:ea typeface="Noto Sans CJK JP"/>
                 <a:cs typeface="Noto Sans"/>
               </a:rPr>
-              <a:t>Diamondを選ぶ専門家の検証記録</a:t>
+              <a:t>Diamond選定における専門家の検証記録</a:t>
             </a:r>
           </a:p>
         </p:txBody>
@@ -16720,7 +16720,7 @@
                 <a:ea typeface="Noto Sans CJK JP"/>
                 <a:cs typeface="Noto Sans"/>
               </a:rPr>
-              <a:t>配布CSVでは、Diamondの198問すべてで最初の専門家検証が正解し、2回目の専門家検証は161問で正解している。</a:t>
+              <a:t>配布CSVでは、Diamondの198問すべてで最初の専門家検証が正解となり、2回目の専門家検証では161問が正解となっている。</a:t>
             </a:r>
           </a:p>
         </p:txBody>
@@ -18682,7 +18682,7 @@
                 <a:ea typeface="Noto Sans CJK JP"/>
                 <a:cs typeface="Noto Sans"/>
               </a:rPr>
-              <a:t>質問文の長さの分布</a:t>
+              <a:t>Diamondの質問文の長さの分布</a:t>
             </a:r>
           </a:p>
         </p:txBody>
@@ -19693,7 +19693,7 @@
                 <a:ea typeface="Noto Sans CJK JP"/>
                 <a:cs typeface="Noto Sans"/>
               </a:rPr>
-              <a:t>各応答は一つの選択肢として採点され、792応答の平均正解率を求める。</a:t>
+              <a:t>各応答で選ばれた一つの選択肢を採点し、全792件の平均正解率を求める。</a:t>
             </a:r>
           </a:p>
         </p:txBody>
@@ -20554,7 +20554,7 @@
                           <a:ea typeface="Noto Sans CJK JP"/>
                           <a:cs typeface="Noto Sans"/>
                         </a:rPr>
-                        <a:t>公式READMEがHugging Face版にも案内している。</a:t>
+                        <a:t>公式READMEでもHugging Face版が案内されている。</a:t>
                       </a:r>
                     </a:p>
                   </a:txBody>
@@ -29353,7 +29353,7 @@
                 <a:ea typeface="Noto Sans CJK JP"/>
                 <a:cs typeface="Noto Sans"/>
               </a:rPr>
-              <a:t>要旨：上向きと下向きの状態が重なった粒子について、指定された観測量の期待値を計算する。</a:t>
+              <a:t>要旨：上向きと下向きの重ね合わせ状態にある粒子について、指定された観測量の期待値を計算する。</a:t>
             </a:r>
           </a:p>
         </p:txBody>
@@ -30990,7 +30990,7 @@
                 <a:ea typeface="Noto Sans CJK JP"/>
                 <a:cs typeface="Noto Sans"/>
               </a:rPr>
-              <a:t>一つの問題で与えられるもの</a:t>
+              <a:t>問題の構成と評価方法</a:t>
             </a:r>
           </a:p>
         </p:txBody>
@@ -36489,7 +36489,7 @@
                 <a:ea typeface="Noto Sans CJK JP"/>
                 <a:cs typeface="Noto Sans"/>
               </a:rPr>
-              <a:t>同じ組成でも、質量が大きい岩石惑星では自分自身の重力による圧縮が強くなる。</a:t>
+              <a:t>同じ組成でも、質量が大きい岩石惑星では自分自身の重力による圧縮が強くなり、平均密度が高くなる。</a:t>
             </a:r>
           </a:p>
           <a:p>
@@ -38812,7 +38812,7 @@
                 <a:ea typeface="Noto Sans CJK JP"/>
                 <a:cs typeface="Noto Sans"/>
               </a:rPr>
-              <a:t>要旨：0.02 MのCa–EDTA錯体と生成定数から、自由なカルシウムイオンの濃度を求める。</a:t>
+              <a:t>要旨：0.02 MのCa–EDTA錯体と生成定数から、遊離カルシウムイオンの濃度を求める。</a:t>
             </a:r>
           </a:p>
         </p:txBody>
@@ -45300,7 +45300,7 @@
                 <a:ea typeface="Noto Sans CJK JP"/>
                 <a:cs typeface="Noto Sans"/>
               </a:rPr>
-              <a:t>一つのピークに対応する官能基だけでなく、複数の測定条件を同時に満たす構造を選ぶ。配布正解はethyl 4-aminobenzoateである。</a:t>
+              <a:t>一つのピークに対応する官能基だけでなく、複数の測定結果を同時に満たす構造を選ぶ。配布正解はethyl 4-aminobenzoateである。</a:t>
             </a:r>
           </a:p>
         </p:txBody>

</xml_diff>

<commit_message>
Improve gpqa answer visibility and citation wording
</commit_message>
<xml_diff>
--- a/slides/datasets-in-10-minutes-gpqa.pptx
+++ b/slides/datasets-in-10-minutes-gpqa.pptx
@@ -8882,7 +8882,7 @@
         <p:spPr>
           <a:xfrm>
             <a:off x="594360" y="4119880"/>
-            <a:ext cx="7955279" cy="347472"/>
+            <a:ext cx="7955279" cy="424645"/>
           </a:xfrm>
           <a:prstGeom prst="rect">
             <a:avLst/>
@@ -8916,7 +8916,7 @@
             <a:r>
               <a:rPr sz="2100" b="1" lang="ja-JP" altLang="en-US">
                 <a:solidFill>
-                  <a:srgbClr val="B13731"/>
+                  <a:schemeClr val="accent1"/>
                 </a:solidFill>
                 <a:latin typeface="Noto Sans"/>
                 <a:ea typeface="Noto Sans CJK JP"/>
@@ -11240,7 +11240,7 @@
         <p:spPr>
           <a:xfrm>
             <a:off x="594360" y="3767328"/>
-            <a:ext cx="7955279" cy="347472"/>
+            <a:ext cx="7955279" cy="424759"/>
           </a:xfrm>
           <a:prstGeom prst="rect">
             <a:avLst/>
@@ -11274,7 +11274,7 @@
             <a:r>
               <a:rPr sz="2100" b="1" lang="ja-JP" altLang="en-US">
                 <a:solidFill>
-                  <a:srgbClr val="B13731"/>
+                  <a:schemeClr val="accent1"/>
                 </a:solidFill>
                 <a:latin typeface="Noto Sans"/>
                 <a:ea typeface="Noto Sans CJK JP"/>
@@ -30127,7 +30127,7 @@
         <p:spPr>
           <a:xfrm>
             <a:off x="594360" y="3767328"/>
-            <a:ext cx="7955279" cy="347472"/>
+            <a:ext cx="7955279" cy="424759"/>
           </a:xfrm>
           <a:prstGeom prst="rect">
             <a:avLst/>
@@ -30161,7 +30161,7 @@
             <a:r>
               <a:rPr sz="2100" b="1" lang="ja-JP" altLang="en-US">
                 <a:solidFill>
-                  <a:srgbClr val="B13731"/>
+                  <a:schemeClr val="accent1"/>
                 </a:solidFill>
                 <a:latin typeface="Noto Sans"/>
                 <a:ea typeface="Noto Sans CJK JP"/>
@@ -31610,7 +31610,7 @@
         <p:spPr>
           <a:xfrm>
             <a:off x="594360" y="4169156"/>
-            <a:ext cx="7955279" cy="347472"/>
+            <a:ext cx="7955279" cy="424683"/>
           </a:xfrm>
           <a:prstGeom prst="rect">
             <a:avLst/>
@@ -31644,7 +31644,7 @@
             <a:r>
               <a:rPr sz="2100" b="1" lang="ja-JP" altLang="en-US">
                 <a:solidFill>
-                  <a:srgbClr val="B13731"/>
+                  <a:schemeClr val="accent1"/>
                 </a:solidFill>
                 <a:latin typeface="Noto Sans"/>
                 <a:ea typeface="Noto Sans CJK JP"/>
@@ -33121,7 +33121,7 @@
         <p:spPr>
           <a:xfrm>
             <a:off x="594360" y="3767328"/>
-            <a:ext cx="7955279" cy="347472"/>
+            <a:ext cx="7955279" cy="424759"/>
           </a:xfrm>
           <a:prstGeom prst="rect">
             <a:avLst/>
@@ -33155,7 +33155,7 @@
             <a:r>
               <a:rPr sz="2100" b="1" lang="ja-JP" altLang="en-US">
                 <a:solidFill>
-                  <a:srgbClr val="B13731"/>
+                  <a:schemeClr val="accent1"/>
                 </a:solidFill>
                 <a:latin typeface="Noto Sans"/>
                 <a:ea typeface="Noto Sans CJK JP"/>
@@ -36239,7 +36239,7 @@
         <p:spPr>
           <a:xfrm>
             <a:off x="594360" y="3767328"/>
-            <a:ext cx="7955279" cy="347472"/>
+            <a:ext cx="7955279" cy="424759"/>
           </a:xfrm>
           <a:prstGeom prst="rect">
             <a:avLst/>
@@ -36273,7 +36273,7 @@
             <a:r>
               <a:rPr sz="2100" b="1" lang="ja-JP" altLang="en-US">
                 <a:solidFill>
-                  <a:srgbClr val="B13731"/>
+                  <a:schemeClr val="accent1"/>
                 </a:solidFill>
                 <a:latin typeface="Noto Sans"/>
                 <a:ea typeface="Noto Sans CJK JP"/>
@@ -37722,7 +37722,7 @@
         <p:spPr>
           <a:xfrm>
             <a:off x="594360" y="3767328"/>
-            <a:ext cx="7955279" cy="347472"/>
+            <a:ext cx="7955279" cy="424759"/>
           </a:xfrm>
           <a:prstGeom prst="rect">
             <a:avLst/>
@@ -37756,7 +37756,7 @@
             <a:r>
               <a:rPr sz="2100" b="1" lang="ja-JP" altLang="en-US">
                 <a:solidFill>
-                  <a:srgbClr val="B13731"/>
+                  <a:schemeClr val="accent1"/>
                 </a:solidFill>
                 <a:latin typeface="Noto Sans"/>
                 <a:ea typeface="Noto Sans CJK JP"/>
@@ -39205,7 +39205,7 @@
         <p:spPr>
           <a:xfrm>
             <a:off x="594360" y="3767328"/>
-            <a:ext cx="7955279" cy="347472"/>
+            <a:ext cx="7955279" cy="424759"/>
           </a:xfrm>
           <a:prstGeom prst="rect">
             <a:avLst/>
@@ -39239,7 +39239,7 @@
             <a:r>
               <a:rPr sz="2100" b="1" lang="ja-JP" altLang="en-US">
                 <a:solidFill>
-                  <a:srgbClr val="B13731"/>
+                  <a:schemeClr val="accent1"/>
                 </a:solidFill>
                 <a:latin typeface="Noto Sans"/>
                 <a:ea typeface="Noto Sans CJK JP"/>
@@ -41125,7 +41125,7 @@
         <p:spPr>
           <a:xfrm>
             <a:off x="594360" y="3767328"/>
-            <a:ext cx="7955279" cy="347472"/>
+            <a:ext cx="7955279" cy="424759"/>
           </a:xfrm>
           <a:prstGeom prst="rect">
             <a:avLst/>
@@ -41159,7 +41159,7 @@
             <a:r>
               <a:rPr sz="2100" b="1" lang="ja-JP" altLang="en-US">
                 <a:solidFill>
-                  <a:srgbClr val="B13731"/>
+                  <a:schemeClr val="accent1"/>
                 </a:solidFill>
                 <a:latin typeface="Noto Sans"/>
                 <a:ea typeface="Noto Sans CJK JP"/>
@@ -42636,7 +42636,7 @@
         <p:spPr>
           <a:xfrm>
             <a:off x="594360" y="3767328"/>
-            <a:ext cx="7955279" cy="347472"/>
+            <a:ext cx="7955279" cy="424759"/>
           </a:xfrm>
           <a:prstGeom prst="rect">
             <a:avLst/>
@@ -42670,7 +42670,7 @@
             <a:r>
               <a:rPr sz="2100" b="1" lang="ja-JP" altLang="en-US">
                 <a:solidFill>
-                  <a:srgbClr val="B13731"/>
+                  <a:schemeClr val="accent1"/>
                 </a:solidFill>
                 <a:latin typeface="Noto Sans"/>
                 <a:ea typeface="Noto Sans CJK JP"/>
@@ -44203,7 +44203,7 @@
         <p:spPr>
           <a:xfrm>
             <a:off x="594360" y="3767328"/>
-            <a:ext cx="7955279" cy="347472"/>
+            <a:ext cx="7955279" cy="424759"/>
           </a:xfrm>
           <a:prstGeom prst="rect">
             <a:avLst/>
@@ -44237,7 +44237,7 @@
             <a:r>
               <a:rPr sz="2100" b="1" lang="ja-JP" altLang="en-US">
                 <a:solidFill>
-                  <a:srgbClr val="B13731"/>
+                  <a:schemeClr val="accent1"/>
                 </a:solidFill>
                 <a:latin typeface="Noto Sans"/>
                 <a:ea typeface="Noto Sans CJK JP"/>
@@ -45305,7 +45305,7 @@
         <p:spPr>
           <a:xfrm>
             <a:off x="594360" y="3767328"/>
-            <a:ext cx="7955279" cy="347472"/>
+            <a:ext cx="7955279" cy="424759"/>
           </a:xfrm>
           <a:prstGeom prst="rect">
             <a:avLst/>
@@ -45339,7 +45339,7 @@
             <a:r>
               <a:rPr sz="2100" b="1" lang="ja-JP" altLang="en-US">
                 <a:solidFill>
-                  <a:srgbClr val="B13731"/>
+                  <a:schemeClr val="accent1"/>
                 </a:solidFill>
                 <a:latin typeface="Noto Sans"/>
                 <a:ea typeface="Noto Sans CJK JP"/>
@@ -46559,7 +46559,7 @@
         <p:spPr>
           <a:xfrm>
             <a:off x="594360" y="3767328"/>
-            <a:ext cx="7955279" cy="347472"/>
+            <a:ext cx="7955279" cy="424759"/>
           </a:xfrm>
           <a:prstGeom prst="rect">
             <a:avLst/>
@@ -46593,7 +46593,7 @@
             <a:r>
               <a:rPr sz="2100" b="1" lang="ja-JP" altLang="en-US">
                 <a:solidFill>
-                  <a:srgbClr val="B13731"/>
+                  <a:schemeClr val="accent1"/>
                 </a:solidFill>
                 <a:latin typeface="Noto Sans"/>
                 <a:ea typeface="Noto Sans CJK JP"/>

</xml_diff>